<commit_message>
feat: create script to remove residual shapes from slide 12 and update presentation file
</commit_message>
<xml_diff>
--- a/Medical_Specialty_Classification_Presentation_v7.pptx
+++ b/Medical_Specialty_Classification_Presentation_v7.pptx
@@ -7347,44 +7347,6 @@
           </a:p>
         </p:txBody>
       </p:sp>
-      <p:sp>
-        <p:nvSpPr>
-          <p:cNvPr id="37" name="Shape 35"/>
-          <p:cNvSpPr/>
-          <p:nvPr/>
-        </p:nvSpPr>
-        <p:spPr>
-          <a:xfrm>
-            <a:off x="457200" y="5257800"/>
-            <a:ext cx="11274552" cy="914400"/>
-          </a:xfrm>
-          <a:prstGeom prst="roundRect">
-            <a:avLst>
-              <a:gd name="adj" fmla="val 9000"/>
-            </a:avLst>
-          </a:prstGeom>
-          <a:solidFill>
-            <a:srgbClr val="FDF6E9"/>
-          </a:solidFill>
-          <a:ln w="12700">
-            <a:solidFill>
-              <a:srgbClr val="E3E8F0"/>
-            </a:solidFill>
-            <a:prstDash val="solid"/>
-          </a:ln>
-          <a:effectLst>
-            <a:outerShdw sx="100000" sy="100000" kx="0" ky="0" algn="bl" rotWithShape="0" blurRad="101600" dist="25400" dir="5400000">
-              <a:srgbClr val="1B2A4A">
-                <a:alpha val="16000"/>
-              </a:srgbClr>
-            </a:outerShdw>
-          </a:effectLst>
-        </p:spPr>
-        <p:txBody>
-          <a:bodyPr/>
-          <a:p/>
-        </p:txBody>
-      </p:sp>
     </p:spTree>
   </p:cSld>
   <p:clrMapOvr>

</xml_diff>

<commit_message>
feat: add script to programmatically generate and update the final 'Thank You' slide in the presentation
</commit_message>
<xml_diff>
--- a/Medical_Specialty_Classification_Presentation_v7.pptx
+++ b/Medical_Specialty_Classification_Presentation_v7.pptx
@@ -12745,16 +12745,16 @@
         </p:nvSpPr>
         <p:spPr>
           <a:xfrm>
-            <a:off x="457200" y="320040"/>
-            <a:ext cx="4206240" cy="292608"/>
+            <a:off x="1294790" y="1234440"/>
+            <a:ext cx="9601200" cy="4389120"/>
           </a:xfrm>
           <a:prstGeom prst="roundRect">
             <a:avLst/>
           </a:prstGeom>
           <a:solidFill>
-            <a:srgbClr val="0E7C86"/>
+            <a:srgbClr val="112240"/>
           </a:solidFill>
-          <a:ln w="12700">
+          <a:ln w="25400">
             <a:solidFill>
               <a:srgbClr val="00E5FF"/>
             </a:solidFill>
@@ -12775,47 +12775,14 @@
           </a:fontRef>
         </p:style>
         <p:txBody>
-          <a:bodyPr rtlCol="0" anchor="ctr"/>
+          <a:bodyPr rtlCol="0" anchor="ctr" wrap="square" tIns="365760" bIns="274320" lIns="365760" rIns="365760"/>
           <a:lstStyle/>
           <a:p>
             <a:pPr algn="ctr">
-              <a:defRPr sz="1050" b="1">
-                <a:solidFill>
-                  <a:srgbClr val="FFFFFF"/>
-                </a:solidFill>
-                <a:latin typeface="Calibri"/>
-              </a:defRPr>
-            </a:pPr>
-            <a:r>
-              <a:t>MCA MINI PROJECT | CONCLUSION</a:t>
-            </a:r>
-          </a:p>
-        </p:txBody>
-      </p:sp>
-      <p:sp>
-        <p:nvSpPr>
-          <p:cNvPr id="4" name="TextBox 3"/>
-          <p:cNvSpPr txBox="1"/>
-          <p:nvPr/>
-        </p:nvSpPr>
-        <p:spPr>
-          <a:xfrm>
-            <a:off x="457200" y="658368"/>
-            <a:ext cx="11247120" cy="621792"/>
-          </a:xfrm>
-          <a:prstGeom prst="rect">
-            <a:avLst/>
-          </a:prstGeom>
-          <a:noFill/>
-        </p:spPr>
-        <p:txBody>
-          <a:bodyPr wrap="none">
-            <a:spAutoFit/>
-          </a:bodyPr>
-          <a:lstStyle/>
-          <a:p>
-            <a:pPr>
-              <a:defRPr sz="2800" b="1">
+              <a:spcAft>
+                <a:spcPts val="800"/>
+              </a:spcAft>
+              <a:defRPr sz="4600" b="1">
                 <a:solidFill>
                   <a:srgbClr val="FFFFFF"/>
                 </a:solidFill>
@@ -12823,165 +12790,15 @@
               </a:defRPr>
             </a:pPr>
             <a:r>
-              <a:t>Conclusion &amp; Implementation Roadmap</a:t>
-            </a:r>
-          </a:p>
-        </p:txBody>
-      </p:sp>
-      <p:sp>
-        <p:nvSpPr>
-          <p:cNvPr id="5" name="TextBox 4"/>
-          <p:cNvSpPr txBox="1"/>
-          <p:nvPr/>
-        </p:nvSpPr>
-        <p:spPr>
-          <a:xfrm>
-            <a:off x="457200" y="6519672"/>
-            <a:ext cx="4206240" cy="274320"/>
-          </a:xfrm>
-          <a:prstGeom prst="rect">
-            <a:avLst/>
-          </a:prstGeom>
-          <a:noFill/>
-        </p:spPr>
-        <p:txBody>
-          <a:bodyPr wrap="none">
-            <a:spAutoFit/>
-          </a:bodyPr>
-          <a:lstStyle/>
-          <a:p>
-            <a:pPr>
-              <a:defRPr sz="900">
-                <a:solidFill>
-                  <a:srgbClr val="94A3B8"/>
-                </a:solidFill>
-                <a:latin typeface="Calibri"/>
-              </a:defRPr>
-            </a:pPr>
-            <a:r>
-              <a:t>Department of Computer Applications | MACE</a:t>
-            </a:r>
-          </a:p>
-        </p:txBody>
-      </p:sp>
-      <p:sp>
-        <p:nvSpPr>
-          <p:cNvPr id="6" name="TextBox 5"/>
-          <p:cNvSpPr txBox="1"/>
-          <p:nvPr/>
-        </p:nvSpPr>
-        <p:spPr>
-          <a:xfrm>
-            <a:off x="3657600" y="6519672"/>
-            <a:ext cx="4873752" cy="274320"/>
-          </a:xfrm>
-          <a:prstGeom prst="rect">
-            <a:avLst/>
-          </a:prstGeom>
-          <a:noFill/>
-        </p:spPr>
-        <p:txBody>
-          <a:bodyPr wrap="none">
-            <a:spAutoFit/>
-          </a:bodyPr>
-          <a:lstStyle/>
-          <a:p>
-            <a:pPr>
-              <a:defRPr sz="900">
-                <a:solidFill>
-                  <a:srgbClr val="94A3B8"/>
-                </a:solidFill>
-                <a:latin typeface="Calibri"/>
-              </a:defRPr>
-            </a:pPr>
-            <a:r>
-              <a:t>Mar Athanasius College of Engineering, Kothamangalam</a:t>
-            </a:r>
-          </a:p>
-        </p:txBody>
-      </p:sp>
-      <p:sp>
-        <p:nvSpPr>
-          <p:cNvPr id="7" name="TextBox 6"/>
-          <p:cNvSpPr txBox="1"/>
-          <p:nvPr/>
-        </p:nvSpPr>
-        <p:spPr>
-          <a:xfrm>
-            <a:off x="9052560" y="6519672"/>
-            <a:ext cx="2679192" cy="274320"/>
-          </a:xfrm>
-          <a:prstGeom prst="rect">
-            <a:avLst/>
-          </a:prstGeom>
-          <a:noFill/>
-        </p:spPr>
-        <p:txBody>
-          <a:bodyPr wrap="none">
-            <a:spAutoFit/>
-          </a:bodyPr>
-          <a:lstStyle/>
-          <a:p>
-            <a:pPr>
-              <a:defRPr sz="900">
-                <a:solidFill>
-                  <a:srgbClr val="94A3B8"/>
-                </a:solidFill>
-                <a:latin typeface="Calibri"/>
-              </a:defRPr>
-            </a:pPr>
-            <a:r>
-              <a:t>Slide 19 of 19</a:t>
-            </a:r>
-          </a:p>
-        </p:txBody>
-      </p:sp>
-      <p:sp>
-        <p:nvSpPr>
-          <p:cNvPr id="8" name="Rounded Rectangle 7"/>
-          <p:cNvSpPr/>
-          <p:nvPr/>
-        </p:nvSpPr>
-        <p:spPr>
-          <a:xfrm>
-            <a:off x="457200" y="1371600"/>
-            <a:ext cx="5440680" cy="3383280"/>
-          </a:xfrm>
-          <a:prstGeom prst="roundRect">
-            <a:avLst/>
-          </a:prstGeom>
-          <a:solidFill>
-            <a:srgbClr val="112240"/>
-          </a:solidFill>
-          <a:ln w="19050">
-            <a:solidFill>
-              <a:srgbClr val="00E5FF"/>
-            </a:solidFill>
-          </a:ln>
-        </p:spPr>
-        <p:style>
-          <a:lnRef idx="1">
-            <a:schemeClr val="accent1"/>
-          </a:lnRef>
-          <a:fillRef idx="3">
-            <a:schemeClr val="accent1"/>
-          </a:fillRef>
-          <a:effectRef idx="2">
-            <a:schemeClr val="accent1"/>
-          </a:effectRef>
-          <a:fontRef idx="minor">
-            <a:schemeClr val="lt1"/>
-          </a:fontRef>
-        </p:style>
-        <p:txBody>
-          <a:bodyPr rtlCol="0" anchor="ctr" wrap="square" lIns="201168" rIns="182880" tIns="164592"/>
-          <a:lstStyle/>
+              <a:t>THANK YOU!</a:t>
+            </a:r>
+          </a:p>
           <a:p>
             <a:pPr algn="ctr">
               <a:spcAft>
-                <a:spcPts val="600"/>
+                <a:spcPts val="1800"/>
               </a:spcAft>
-              <a:defRPr sz="1200" b="1">
+              <a:defRPr sz="2000" b="1">
                 <a:solidFill>
                   <a:srgbClr val="38BDF8"/>
                 </a:solidFill>
@@ -12989,395 +12806,27 @@
               </a:defRPr>
             </a:pPr>
             <a:r>
-              <a:t>KEY PHASE 1 ACHIEVEMENTS (SPRINT RELEASE I)</a:t>
-            </a:r>
-          </a:p>
-          <a:p>
-            <a:pPr>
-              <a:spcAft>
-                <a:spcPts val="300"/>
-              </a:spcAft>
-            </a:pPr>
-            <a:r>
-              <a:rPr sz="1000" b="1">
-                <a:solidFill>
-                  <a:srgbClr val="4ADE80"/>
-                </a:solidFill>
-                <a:latin typeface="Calibri"/>
-              </a:rPr>
-              <a:t>✓ Problem Addressed: </a:t>
-            </a:r>
-            <a:r>
-              <a:rPr sz="919" b="0">
-                <a:solidFill>
-                  <a:srgbClr val="F1F5F9"/>
-                </a:solidFill>
-                <a:latin typeface="Calibri"/>
-              </a:rPr>
-              <a:t>Formulated automated routing for unstructured clinical narratives across 40 distinct medical specialties.</a:t>
-            </a:r>
-          </a:p>
-          <a:p>
-            <a:pPr>
-              <a:spcAft>
-                <a:spcPts val="300"/>
-              </a:spcAft>
-            </a:pPr>
-            <a:r>
-              <a:rPr sz="1000" b="1">
-                <a:solidFill>
-                  <a:srgbClr val="4ADE80"/>
-                </a:solidFill>
-                <a:latin typeface="Calibri"/>
-              </a:rPr>
-              <a:t>✓ Data Audit Complete: </a:t>
-            </a:r>
-            <a:r>
-              <a:rPr sz="919" b="0">
-                <a:solidFill>
-                  <a:srgbClr val="F1F5F9"/>
-                </a:solidFill>
-                <a:latin typeface="Calibri"/>
-              </a:rPr>
-              <a:t>Cleaned 4,999 MTSamples records; audited nulls and isolated 4,966 validated clinical transcripts.</a:t>
-            </a:r>
-          </a:p>
-          <a:p>
-            <a:pPr>
-              <a:spcAft>
-                <a:spcPts val="300"/>
-              </a:spcAft>
-            </a:pPr>
-            <a:r>
-              <a:rPr sz="1000" b="1">
-                <a:solidFill>
-                  <a:srgbClr val="4ADE80"/>
-                </a:solidFill>
-                <a:latin typeface="Calibri"/>
-              </a:rPr>
-              <a:t>✓ In-Depth EDA Executed: </a:t>
-            </a:r>
-            <a:r>
-              <a:rPr sz="919" b="0">
-                <a:solidFill>
-                  <a:srgbClr val="F1F5F9"/>
-                </a:solidFill>
-                <a:latin typeface="Calibri"/>
-              </a:rPr>
-              <a:t>Characterized severe long-tail class skew, document token density, and vocabulary distribution patterns.</a:t>
-            </a:r>
-          </a:p>
-          <a:p>
-            <a:pPr>
-              <a:spcAft>
-                <a:spcPts val="300"/>
-              </a:spcAft>
-            </a:pPr>
-            <a:r>
-              <a:rPr sz="1000" b="1">
-                <a:solidFill>
-                  <a:srgbClr val="4ADE80"/>
-                </a:solidFill>
-                <a:latin typeface="Calibri"/>
-              </a:rPr>
-              <a:t>✓ Leakage-Free Pipeline: </a:t>
-            </a:r>
-            <a:r>
-              <a:rPr sz="919" b="0">
-                <a:solidFill>
-                  <a:srgbClr val="F1F5F9"/>
-                </a:solidFill>
-                <a:latin typeface="Calibri"/>
-              </a:rPr>
-              <a:t>Designed modular 8-step NLP cleaner with strict train-only TF-IDF vectorization to avoid data leakage.</a:t>
-            </a:r>
-          </a:p>
-          <a:p>
-            <a:pPr>
-              <a:spcAft>
-                <a:spcPts val="300"/>
-              </a:spcAft>
-            </a:pPr>
-            <a:r>
-              <a:rPr sz="1000" b="1">
-                <a:solidFill>
-                  <a:srgbClr val="4ADE80"/>
-                </a:solidFill>
-                <a:latin typeface="Calibri"/>
-              </a:rPr>
-              <a:t>✓ Architecture Established: </a:t>
-            </a:r>
-            <a:r>
-              <a:rPr sz="919" b="0">
-                <a:solidFill>
-                  <a:srgbClr val="F1F5F9"/>
-                </a:solidFill>
-                <a:latin typeface="Calibri"/>
-              </a:rPr>
-              <a:t>Selected 4 diverse classifiers (SVM, RF, LR, MNB) unified under a Soft-Voting probability consensus model.</a:t>
-            </a:r>
-          </a:p>
-        </p:txBody>
-      </p:sp>
-      <p:sp>
-        <p:nvSpPr>
-          <p:cNvPr id="9" name="Rounded Rectangle 8"/>
-          <p:cNvSpPr/>
-          <p:nvPr/>
-        </p:nvSpPr>
-        <p:spPr>
-          <a:xfrm>
-            <a:off x="6217920" y="1371600"/>
-            <a:ext cx="5486400" cy="3383280"/>
-          </a:xfrm>
-          <a:prstGeom prst="roundRect">
-            <a:avLst/>
-          </a:prstGeom>
-          <a:solidFill>
-            <a:srgbClr val="112240"/>
-          </a:solidFill>
-          <a:ln w="19050">
-            <a:solidFill>
-              <a:srgbClr val="C084FC"/>
-            </a:solidFill>
-          </a:ln>
-        </p:spPr>
-        <p:style>
-          <a:lnRef idx="1">
-            <a:schemeClr val="accent1"/>
-          </a:lnRef>
-          <a:fillRef idx="3">
-            <a:schemeClr val="accent1"/>
-          </a:fillRef>
-          <a:effectRef idx="2">
-            <a:schemeClr val="accent1"/>
-          </a:effectRef>
-          <a:fontRef idx="minor">
-            <a:schemeClr val="lt1"/>
-          </a:fontRef>
-        </p:style>
-        <p:txBody>
-          <a:bodyPr rtlCol="0" anchor="ctr" wrap="square" lIns="201168" rIns="182880" tIns="164592"/>
-          <a:lstStyle/>
+              <a:t>Questions, Suggestions &amp; Discussion</a:t>
+            </a:r>
+          </a:p>
           <a:p>
             <a:pPr algn="ctr">
               <a:spcAft>
-                <a:spcPts val="600"/>
+                <a:spcPts val="2000"/>
               </a:spcAft>
-              <a:defRPr sz="1200" b="1">
-                <a:solidFill>
-                  <a:srgbClr val="C084FC"/>
-                </a:solidFill>
-                <a:latin typeface="Calibri"/>
-              </a:defRPr>
-            </a:pPr>
-            <a:r>
-              <a:t>PLANNED NEXT STEPS (PHASES 2 &amp; 3)</a:t>
-            </a:r>
-          </a:p>
-          <a:p>
-            <a:pPr>
-              <a:spcAft>
-                <a:spcPts val="300"/>
-              </a:spcAft>
-            </a:pPr>
-            <a:r>
-              <a:rPr sz="1000" b="1">
-                <a:solidFill>
-                  <a:srgbClr val="60A5FA"/>
-                </a:solidFill>
-                <a:latin typeface="Calibri"/>
-              </a:rPr>
-              <a:t>→ Execute Cleaning Pipeline: </a:t>
-            </a:r>
-            <a:r>
-              <a:rPr sz="919" b="0">
+              <a:defRPr sz="1700" b="1">
                 <a:solidFill>
                   <a:srgbClr val="F1F5F9"/>
-                </a:solidFill>
-                <a:latin typeface="Calibri"/>
-              </a:rPr>
-              <a:t>Apply modular character normalization, stop-word pruning, and lemmatization across 4,966 records.</a:t>
-            </a:r>
-          </a:p>
-          <a:p>
-            <a:pPr>
-              <a:spcAft>
-                <a:spcPts val="300"/>
-              </a:spcAft>
-            </a:pPr>
-            <a:r>
-              <a:rPr sz="1000" b="1">
-                <a:solidFill>
-                  <a:srgbClr val="60A5FA"/>
-                </a:solidFill>
-                <a:latin typeface="Calibri"/>
-              </a:rPr>
-              <a:t>→ Feature Matrix Extraction: </a:t>
-            </a:r>
-            <a:r>
-              <a:rPr sz="919" b="0">
-                <a:solidFill>
-                  <a:srgbClr val="F1F5F9"/>
-                </a:solidFill>
-                <a:latin typeface="Calibri"/>
-              </a:rPr>
-              <a:t>Fit TF-IDF vectorizer strictly on training split (80:20) with sublinear term-frequency scaling.</a:t>
-            </a:r>
-          </a:p>
-          <a:p>
-            <a:pPr>
-              <a:spcAft>
-                <a:spcPts val="300"/>
-              </a:spcAft>
-            </a:pPr>
-            <a:r>
-              <a:rPr sz="1000" b="1">
-                <a:solidFill>
-                  <a:srgbClr val="60A5FA"/>
-                </a:solidFill>
-                <a:latin typeface="Calibri"/>
-              </a:rPr>
-              <a:t>→ Train &amp; Tune Estimators: </a:t>
-            </a:r>
-            <a:r>
-              <a:rPr sz="919" b="0">
-                <a:solidFill>
-                  <a:srgbClr val="F1F5F9"/>
-                </a:solidFill>
-                <a:latin typeface="Calibri"/>
-              </a:rPr>
-              <a:t>Train SVM, Random Forest, Logistic Regression, and MNB classifiers; execute hyperparameter grid tuning.</a:t>
-            </a:r>
-          </a:p>
-          <a:p>
-            <a:pPr>
-              <a:spcAft>
-                <a:spcPts val="300"/>
-              </a:spcAft>
-            </a:pPr>
-            <a:r>
-              <a:rPr sz="1000" b="1">
-                <a:solidFill>
-                  <a:srgbClr val="60A5FA"/>
-                </a:solidFill>
-                <a:latin typeface="Calibri"/>
-              </a:rPr>
-              <a:t>→ Build Soft Voting Ensemble: </a:t>
-            </a:r>
-            <a:r>
-              <a:rPr sz="919" b="0">
-                <a:solidFill>
-                  <a:srgbClr val="F1F5F9"/>
-                </a:solidFill>
-                <a:latin typeface="Calibri"/>
-              </a:rPr>
-              <a:t>Implement soft consensus probability aggregation combining calibrated predictive distributions.</a:t>
-            </a:r>
-          </a:p>
-          <a:p>
-            <a:pPr>
-              <a:spcAft>
-                <a:spcPts val="300"/>
-              </a:spcAft>
-            </a:pPr>
-            <a:r>
-              <a:rPr sz="1000" b="1">
-                <a:solidFill>
-                  <a:srgbClr val="60A5FA"/>
-                </a:solidFill>
-                <a:latin typeface="Calibri"/>
-              </a:rPr>
-              <a:t>→ Multi-Class Evaluation: </a:t>
-            </a:r>
-            <a:r>
-              <a:rPr sz="919" b="0">
-                <a:solidFill>
-                  <a:srgbClr val="F1F5F9"/>
-                </a:solidFill>
-                <a:latin typeface="Calibri"/>
-              </a:rPr>
-              <a:t>Benchmark Macro/Weighted F1, Recall, Precision, and cross-category Confusion Matrices.</a:t>
-            </a:r>
-          </a:p>
-          <a:p>
-            <a:pPr>
-              <a:spcAft>
-                <a:spcPts val="300"/>
-              </a:spcAft>
-            </a:pPr>
-            <a:r>
-              <a:rPr sz="1000" b="1">
-                <a:solidFill>
-                  <a:srgbClr val="60A5FA"/>
-                </a:solidFill>
-                <a:latin typeface="Calibri"/>
-              </a:rPr>
-              <a:t>→ Deployment &amp; Serialization: </a:t>
-            </a:r>
-            <a:r>
-              <a:rPr sz="919" b="0">
-                <a:solidFill>
-                  <a:srgbClr val="F1F5F9"/>
-                </a:solidFill>
-                <a:latin typeface="Calibri"/>
-              </a:rPr>
-              <a:t>Serialize pipeline with Joblib; construct interactive clinician dashboard using Flask.</a:t>
-            </a:r>
-          </a:p>
-        </p:txBody>
-      </p:sp>
-      <p:sp>
-        <p:nvSpPr>
-          <p:cNvPr id="10" name="Rounded Rectangle 9"/>
-          <p:cNvSpPr/>
-          <p:nvPr/>
-        </p:nvSpPr>
-        <p:spPr>
-          <a:xfrm>
-            <a:off x="457200" y="4892040"/>
-            <a:ext cx="11247120" cy="1463040"/>
-          </a:xfrm>
-          <a:prstGeom prst="roundRect">
-            <a:avLst/>
-          </a:prstGeom>
-          <a:solidFill>
-            <a:srgbClr val="0E2A54"/>
-          </a:solidFill>
-          <a:ln w="25400">
-            <a:solidFill>
-              <a:srgbClr val="00E5FF"/>
-            </a:solidFill>
-          </a:ln>
-        </p:spPr>
-        <p:style>
-          <a:lnRef idx="1">
-            <a:schemeClr val="accent1"/>
-          </a:lnRef>
-          <a:fillRef idx="3">
-            <a:schemeClr val="accent1"/>
-          </a:fillRef>
-          <a:effectRef idx="2">
-            <a:schemeClr val="accent1"/>
-          </a:effectRef>
-          <a:fontRef idx="minor">
-            <a:schemeClr val="lt1"/>
-          </a:fontRef>
-        </p:style>
-        <p:txBody>
-          <a:bodyPr rtlCol="0" anchor="ctr" wrap="square" tIns="164592"/>
-          <a:lstStyle/>
-          <a:p>
-            <a:pPr algn="ctr">
-              <a:defRPr sz="2800" b="1">
-                <a:solidFill>
-                  <a:srgbClr val="FFFFFF"/>
                 </a:solidFill>
                 <a:latin typeface="Cambria"/>
               </a:defRPr>
             </a:pPr>
             <a:r>
-              <a:t>THANK YOU!</a:t>
+              <a:t>Medical Specialty Classification Using TF-IDF</a:t>
+            </a:r>
+            <a:br/>
+            <a:r>
+              <a:t>and Ensemble Machine Learning</a:t>
             </a:r>
           </a:p>
           <a:p>
@@ -13385,20 +12834,36 @@
               <a:spcAft>
                 <a:spcPts val="400"/>
               </a:spcAft>
-              <a:defRPr sz="1500" b="1">
-                <a:solidFill>
-                  <a:srgbClr val="38BDF8"/>
+              <a:defRPr sz="1350" b="1">
+                <a:solidFill>
+                  <a:srgbClr val="4ADE80"/>
                 </a:solidFill>
                 <a:latin typeface="Calibri"/>
               </a:defRPr>
             </a:pPr>
             <a:r>
-              <a:t>Questions, Suggestions &amp; Discussions are Welcome</a:t>
+              <a:t>Presented by: Jiphin George (Register No: MAC25MCA-2033)</a:t>
             </a:r>
           </a:p>
           <a:p>
             <a:pPr algn="ctr">
-              <a:defRPr sz="1100">
+              <a:spcAft>
+                <a:spcPts val="400"/>
+              </a:spcAft>
+              <a:defRPr sz="1250" b="0">
+                <a:solidFill>
+                  <a:srgbClr val="E2E8F0"/>
+                </a:solidFill>
+                <a:latin typeface="Calibri"/>
+              </a:defRPr>
+            </a:pPr>
+            <a:r>
+              <a:t>Project Guide: Prof. Biju Skaria  |  Department of Computer Applications</a:t>
+            </a:r>
+          </a:p>
+          <a:p>
+            <a:pPr algn="ctr">
+              <a:defRPr sz="1150" b="0">
                 <a:solidFill>
                   <a:srgbClr val="94A3B8"/>
                 </a:solidFill>
@@ -13406,7 +12871,115 @@
               </a:defRPr>
             </a:pPr>
             <a:r>
-              <a:t>Student: Jiphin George (MAC25MCA-2033)  |  Project Guide: Prof. Biju Skaria  |  MCA Mini Project (Semester 3)</a:t>
+              <a:t>Mar Athanasius College of Engineering, Kothamangalam  |  MCA Mini Project (Semester 3)</a:t>
+            </a:r>
+          </a:p>
+        </p:txBody>
+      </p:sp>
+      <p:sp>
+        <p:nvSpPr>
+          <p:cNvPr id="4" name="TextBox 3"/>
+          <p:cNvSpPr txBox="1"/>
+          <p:nvPr/>
+        </p:nvSpPr>
+        <p:spPr>
+          <a:xfrm>
+            <a:off x="457200" y="6519672"/>
+            <a:ext cx="4206240" cy="274320"/>
+          </a:xfrm>
+          <a:prstGeom prst="rect">
+            <a:avLst/>
+          </a:prstGeom>
+          <a:noFill/>
+        </p:spPr>
+        <p:txBody>
+          <a:bodyPr wrap="none">
+            <a:spAutoFit/>
+          </a:bodyPr>
+          <a:lstStyle/>
+          <a:p>
+            <a:pPr>
+              <a:defRPr sz="900">
+                <a:solidFill>
+                  <a:srgbClr val="94A3B8"/>
+                </a:solidFill>
+                <a:latin typeface="Calibri"/>
+              </a:defRPr>
+            </a:pPr>
+            <a:r>
+              <a:t>Department of Computer Applications | MACE</a:t>
+            </a:r>
+          </a:p>
+        </p:txBody>
+      </p:sp>
+      <p:sp>
+        <p:nvSpPr>
+          <p:cNvPr id="5" name="TextBox 4"/>
+          <p:cNvSpPr txBox="1"/>
+          <p:nvPr/>
+        </p:nvSpPr>
+        <p:spPr>
+          <a:xfrm>
+            <a:off x="3657600" y="6519672"/>
+            <a:ext cx="4873752" cy="274320"/>
+          </a:xfrm>
+          <a:prstGeom prst="rect">
+            <a:avLst/>
+          </a:prstGeom>
+          <a:noFill/>
+        </p:spPr>
+        <p:txBody>
+          <a:bodyPr wrap="none">
+            <a:spAutoFit/>
+          </a:bodyPr>
+          <a:lstStyle/>
+          <a:p>
+            <a:pPr>
+              <a:defRPr sz="900">
+                <a:solidFill>
+                  <a:srgbClr val="94A3B8"/>
+                </a:solidFill>
+                <a:latin typeface="Calibri"/>
+              </a:defRPr>
+            </a:pPr>
+            <a:r>
+              <a:t>Mar Athanasius College of Engineering, Kothamangalam</a:t>
+            </a:r>
+          </a:p>
+        </p:txBody>
+      </p:sp>
+      <p:sp>
+        <p:nvSpPr>
+          <p:cNvPr id="6" name="TextBox 5"/>
+          <p:cNvSpPr txBox="1"/>
+          <p:nvPr/>
+        </p:nvSpPr>
+        <p:spPr>
+          <a:xfrm>
+            <a:off x="9052560" y="6519672"/>
+            <a:ext cx="2679192" cy="274320"/>
+          </a:xfrm>
+          <a:prstGeom prst="rect">
+            <a:avLst/>
+          </a:prstGeom>
+          <a:noFill/>
+        </p:spPr>
+        <p:txBody>
+          <a:bodyPr wrap="none">
+            <a:spAutoFit/>
+          </a:bodyPr>
+          <a:lstStyle/>
+          <a:p>
+            <a:pPr>
+              <a:defRPr sz="900">
+                <a:solidFill>
+                  <a:srgbClr val="94A3B8"/>
+                </a:solidFill>
+                <a:latin typeface="Calibri"/>
+              </a:defRPr>
+            </a:pPr>
+            <a:r>
+              <a:t>Slide 19 of 19</a:t>
             </a:r>
           </a:p>
         </p:txBody>

</xml_diff>